<commit_message>
Update pipeline figure in docs and slides
Co-Authored-By: Claude Sonnet 5.5 <noreply@anthropic.com>
</commit_message>
<xml_diff>
--- a/presentation/Systematic Evaluation of Signal-to-Image Transformation Pipelines for Vision Transformer-based Sleep Stage Classification - Presentation.pptx
+++ b/presentation/Systematic Evaluation of Signal-to-Image Transformation Pipelines for Vision Transformer-based Sleep Stage Classification - Presentation.pptx
@@ -11111,22 +11111,22 @@
       </p:sp>
       <p:pic>
         <p:nvPicPr>
-          <p:cNvPr id="9" name="Figure 1 pipeline" descr="fig1c.png"/>
+          <p:cNvPr id="11" name="Figure 1 pipeline" descr="new_crop.png"/>
           <p:cNvPicPr>
             <a:picLocks noChangeAspect="1"/>
           </p:cNvPicPr>
           <p:nvPr/>
         </p:nvPicPr>
         <p:blipFill>
-          <a:blip r:embed="rId4"/>
+          <a:blip r:embed="rId3"/>
           <a:stretch>
             <a:fillRect/>
           </a:stretch>
         </p:blipFill>
         <p:spPr>
           <a:xfrm>
-            <a:off x="1931408" y="1508760"/>
-            <a:ext cx="8328877" cy="4023360"/>
+            <a:off x="1931408" y="1543586"/>
+            <a:ext cx="8328877" cy="3953707"/>
           </a:xfrm>
           <a:prstGeom prst="rect">
             <a:avLst/>

</xml_diff>

<commit_message>
Use morph, push and wipe transitions
Co-Authored-By: Claude Sonnet 5.5 <noreply@anthropic.com>
</commit_message>
<xml_diff>
--- a/presentation/Systematic Evaluation of Signal-to-Image Transformation Pipelines for Vision Transformer-based Sleep Stage Classification - Presentation.pptx
+++ b/presentation/Systematic Evaluation of Signal-to-Image Transformation Pipelines for Vision Transformer-based Sleep Stage Classification - Presentation.pptx
@@ -6013,7 +6013,7 @@
   </p:clrMapOvr>
   <mc:AlternateContent xmlns:mc="http://schemas.openxmlformats.org/markup-compatibility/2006">
     <mc:Choice xmlns:p14="http://schemas.microsoft.com/office/powerpoint/2010/main" Requires="p14">
-      <p:transition spd="med" p14:dur="600">
+      <p:transition spd="med" p14:dur="700">
         <p:fade/>
       </p:transition>
     </mc:Choice>
@@ -6852,13 +6852,13 @@
     <a:masterClrMapping/>
   </p:clrMapOvr>
   <mc:AlternateContent xmlns:mc="http://schemas.openxmlformats.org/markup-compatibility/2006">
-    <mc:Choice xmlns:p14="http://schemas.microsoft.com/office/powerpoint/2010/main" Requires="p14">
-      <p:transition spd="med" p14:dur="600">
-        <p:fade/>
+    <mc:Choice xmlns:p159="http://schemas.microsoft.com/office/powerpoint/2015/09/main" xmlns:p14="http://schemas.microsoft.com/office/powerpoint/2010/main" Requires="p159">
+      <p:transition spd="slow" p14:dur="1200">
+        <p159:morph option="byObject"/>
       </p:transition>
     </mc:Choice>
     <mc:Fallback>
-      <p:transition spd="med">
+      <p:transition spd="slow">
         <p:fade/>
       </p:transition>
     </mc:Fallback>
@@ -7275,13 +7275,13 @@
   </p:clrMapOvr>
   <mc:AlternateContent xmlns:mc="http://schemas.openxmlformats.org/markup-compatibility/2006">
     <mc:Choice xmlns:p14="http://schemas.microsoft.com/office/powerpoint/2010/main" Requires="p14">
-      <p:transition spd="med" p14:dur="600">
-        <p:fade/>
+      <p:transition spd="med" p14:dur="700">
+        <p:push dir="l"/>
       </p:transition>
     </mc:Choice>
     <mc:Fallback>
       <p:transition spd="med">
-        <p:fade/>
+        <p:push dir="l"/>
       </p:transition>
     </mc:Fallback>
   </mc:AlternateContent>
@@ -8426,13 +8426,13 @@
     <a:masterClrMapping/>
   </p:clrMapOvr>
   <mc:AlternateContent xmlns:mc="http://schemas.openxmlformats.org/markup-compatibility/2006">
-    <mc:Choice xmlns:p14="http://schemas.microsoft.com/office/powerpoint/2010/main" Requires="p14">
-      <p:transition spd="med" p14:dur="600">
-        <p:fade/>
+    <mc:Choice xmlns:p159="http://schemas.microsoft.com/office/powerpoint/2015/09/main" xmlns:p14="http://schemas.microsoft.com/office/powerpoint/2010/main" Requires="p159">
+      <p:transition spd="slow" p14:dur="1200">
+        <p159:morph option="byObject"/>
       </p:transition>
     </mc:Choice>
     <mc:Fallback>
-      <p:transition spd="med">
+      <p:transition spd="slow">
         <p:fade/>
       </p:transition>
     </mc:Fallback>
@@ -8788,7 +8788,7 @@
   </p:clrMapOvr>
   <mc:AlternateContent xmlns:mc="http://schemas.openxmlformats.org/markup-compatibility/2006">
     <mc:Choice xmlns:p14="http://schemas.microsoft.com/office/powerpoint/2010/main" Requires="p14">
-      <p:transition spd="med" p14:dur="600">
+      <p:transition spd="med" p14:dur="700">
         <p:fade/>
       </p:transition>
     </mc:Choice>
@@ -9831,13 +9831,13 @@
     <a:masterClrMapping/>
   </p:clrMapOvr>
   <mc:AlternateContent xmlns:mc="http://schemas.openxmlformats.org/markup-compatibility/2006">
-    <mc:Choice xmlns:p14="http://schemas.microsoft.com/office/powerpoint/2010/main" Requires="p14">
-      <p:transition spd="med" p14:dur="600">
-        <p:fade/>
+    <mc:Choice xmlns:p159="http://schemas.microsoft.com/office/powerpoint/2015/09/main" xmlns:p14="http://schemas.microsoft.com/office/powerpoint/2010/main" Requires="p159">
+      <p:transition spd="slow" p14:dur="1200">
+        <p159:morph option="byObject"/>
       </p:transition>
     </mc:Choice>
     <mc:Fallback>
-      <p:transition spd="med">
+      <p:transition spd="slow">
         <p:fade/>
       </p:transition>
     </mc:Fallback>
@@ -10737,13 +10737,13 @@
     <a:masterClrMapping/>
   </p:clrMapOvr>
   <mc:AlternateContent xmlns:mc="http://schemas.openxmlformats.org/markup-compatibility/2006">
-    <mc:Choice xmlns:p14="http://schemas.microsoft.com/office/powerpoint/2010/main" Requires="p14">
-      <p:transition spd="med" p14:dur="600">
-        <p:fade/>
+    <mc:Choice xmlns:p159="http://schemas.microsoft.com/office/powerpoint/2015/09/main" xmlns:p14="http://schemas.microsoft.com/office/powerpoint/2010/main" Requires="p159">
+      <p:transition spd="slow" p14:dur="1200">
+        <p159:morph option="byObject"/>
       </p:transition>
     </mc:Choice>
     <mc:Fallback>
-      <p:transition spd="med">
+      <p:transition spd="slow">
         <p:fade/>
       </p:transition>
     </mc:Fallback>
@@ -11539,13 +11539,13 @@
   </p:clrMapOvr>
   <mc:AlternateContent xmlns:mc="http://schemas.openxmlformats.org/markup-compatibility/2006">
     <mc:Choice xmlns:p14="http://schemas.microsoft.com/office/powerpoint/2010/main" Requires="p14">
-      <p:transition spd="med" p14:dur="600">
-        <p:fade/>
+      <p:transition spd="med" p14:dur="700">
+        <p:push dir="l"/>
       </p:transition>
     </mc:Choice>
     <mc:Fallback>
       <p:transition spd="med">
-        <p:fade/>
+        <p:push dir="l"/>
       </p:transition>
     </mc:Fallback>
   </mc:AlternateContent>
@@ -11855,13 +11855,13 @@
   </p:clrMapOvr>
   <mc:AlternateContent xmlns:mc="http://schemas.openxmlformats.org/markup-compatibility/2006">
     <mc:Choice xmlns:p14="http://schemas.microsoft.com/office/powerpoint/2010/main" Requires="p14">
-      <p:transition spd="med" p14:dur="600">
-        <p:fade/>
+      <p:transition spd="med" p14:dur="700">
+        <p:wipe dir="r"/>
       </p:transition>
     </mc:Choice>
     <mc:Fallback>
       <p:transition spd="med">
-        <p:fade/>
+        <p:wipe dir="r"/>
       </p:transition>
     </mc:Fallback>
   </mc:AlternateContent>
@@ -13148,13 +13148,13 @@
   </p:clrMapOvr>
   <mc:AlternateContent xmlns:mc="http://schemas.openxmlformats.org/markup-compatibility/2006">
     <mc:Choice xmlns:p14="http://schemas.microsoft.com/office/powerpoint/2010/main" Requires="p14">
-      <p:transition spd="med" p14:dur="600">
-        <p:fade/>
+      <p:transition spd="med" p14:dur="700">
+        <p:push dir="l"/>
       </p:transition>
     </mc:Choice>
     <mc:Fallback>
       <p:transition spd="med">
-        <p:fade/>
+        <p:push dir="l"/>
       </p:transition>
     </mc:Fallback>
   </mc:AlternateContent>
@@ -13988,13 +13988,13 @@
   </p:clrMapOvr>
   <mc:AlternateContent xmlns:mc="http://schemas.openxmlformats.org/markup-compatibility/2006">
     <mc:Choice xmlns:p14="http://schemas.microsoft.com/office/powerpoint/2010/main" Requires="p14">
-      <p:transition spd="med" p14:dur="600">
-        <p:fade/>
+      <p:transition spd="med" p14:dur="700">
+        <p:push dir="l"/>
       </p:transition>
     </mc:Choice>
     <mc:Fallback>
       <p:transition spd="med">
-        <p:fade/>
+        <p:push dir="l"/>
       </p:transition>
     </mc:Fallback>
   </mc:AlternateContent>
@@ -14827,13 +14827,13 @@
     <a:masterClrMapping/>
   </p:clrMapOvr>
   <mc:AlternateContent xmlns:mc="http://schemas.openxmlformats.org/markup-compatibility/2006">
-    <mc:Choice xmlns:p14="http://schemas.microsoft.com/office/powerpoint/2010/main" Requires="p14">
-      <p:transition spd="med" p14:dur="600">
-        <p:fade/>
+    <mc:Choice xmlns:p159="http://schemas.microsoft.com/office/powerpoint/2015/09/main" xmlns:p14="http://schemas.microsoft.com/office/powerpoint/2010/main" Requires="p159">
+      <p:transition spd="slow" p14:dur="1200">
+        <p159:morph option="byObject"/>
       </p:transition>
     </mc:Choice>
     <mc:Fallback>
-      <p:transition spd="med">
+      <p:transition spd="slow">
         <p:fade/>
       </p:transition>
     </mc:Fallback>
@@ -15667,13 +15667,13 @@
     <a:masterClrMapping/>
   </p:clrMapOvr>
   <mc:AlternateContent xmlns:mc="http://schemas.openxmlformats.org/markup-compatibility/2006">
-    <mc:Choice xmlns:p14="http://schemas.microsoft.com/office/powerpoint/2010/main" Requires="p14">
-      <p:transition spd="med" p14:dur="600">
-        <p:fade/>
+    <mc:Choice xmlns:p159="http://schemas.microsoft.com/office/powerpoint/2015/09/main" xmlns:p14="http://schemas.microsoft.com/office/powerpoint/2010/main" Requires="p159">
+      <p:transition spd="slow" p14:dur="1200">
+        <p159:morph option="byObject"/>
       </p:transition>
     </mc:Choice>
     <mc:Fallback>
-      <p:transition spd="med">
+      <p:transition spd="slow">
         <p:fade/>
       </p:transition>
     </mc:Fallback>

</xml_diff>

<commit_message>
Center title block and add University of Colombo logo
Co-Authored-By: Claude Sonnet 5.5 <noreply@anthropic.com>
</commit_message>
<xml_diff>
--- a/presentation/Systematic Evaluation of Signal-to-Image Transformation Pipelines for Vision Transformer-based Sleep Stage Classification - Presentation.pptx
+++ b/presentation/Systematic Evaluation of Signal-to-Image Transformation Pipelines for Vision Transformer-based Sleep Stage Classification - Presentation.pptx
@@ -5689,7 +5689,7 @@
         </p:nvSpPr>
         <p:spPr>
           <a:xfrm>
-            <a:off x="1280160" y="1828800"/>
+            <a:off x="1280160" y="2850000"/>
             <a:ext cx="9966960" cy="1828800"/>
           </a:xfrm>
         </p:spPr>
@@ -5775,7 +5775,7 @@
         </p:nvSpPr>
         <p:spPr>
           <a:xfrm>
-            <a:off x="1280160" y="4023360"/>
+            <a:off x="1280160" y="4800000"/>
             <a:ext cx="9966960" cy="1463040"/>
           </a:xfrm>
           <a:prstGeom prst="rect">
@@ -5995,6 +5995,30 @@
           <a:xfrm>
             <a:off x="9045683" y="170912"/>
             <a:ext cx="1393723" cy="711201"/>
+          </a:xfrm>
+          <a:prstGeom prst="rect">
+            <a:avLst/>
+          </a:prstGeom>
+        </p:spPr>
+      </p:pic>
+      <p:pic>
+        <p:nvPicPr>
+          <p:cNvPr id="23" name="University of Colombo logo" descr="Universityof-colombo.png"/>
+          <p:cNvPicPr>
+            <a:picLocks noChangeAspect="1"/>
+          </p:cNvPicPr>
+          <p:nvPr/>
+        </p:nvPicPr>
+        <p:blipFill>
+          <a:blip r:embed="rId5"/>
+          <a:stretch>
+            <a:fillRect/>
+          </a:stretch>
+        </p:blipFill>
+        <p:spPr>
+          <a:xfrm>
+            <a:off x="5718433" y="1450000"/>
+            <a:ext cx="1090415" cy="1250000"/>
           </a:xfrm>
           <a:prstGeom prst="rect">
             <a:avLst/>

</xml_diff>

<commit_message>
Add example-image slides for transformations, FFT/DWT and DCGAN; update notes
Co-Authored-By: Claude Sonnet 5.5 <noreply@anthropic.com>
</commit_message>
<xml_diff>
--- a/presentation/Systematic Evaluation of Signal-to-Image Transformation Pipelines for Vision Transformer-based Sleep Stage Classification - Presentation.pptx
+++ b/presentation/Systematic Evaluation of Signal-to-Image Transformation Pipelines for Vision Transformer-based Sleep Stage Classification - Presentation.pptx
@@ -17,8 +17,11 @@
     <p:sldId id="262" r:id="rId5"/>
     <p:sldId id="263" r:id="rId6"/>
     <p:sldId id="264" r:id="rId7"/>
+    <p:sldId id="272" r:id="rId21"/>
     <p:sldId id="265" r:id="rId8"/>
+    <p:sldId id="273" r:id="rId22"/>
     <p:sldId id="266" r:id="rId9"/>
+    <p:sldId id="274" r:id="rId23"/>
     <p:sldId id="267" r:id="rId10"/>
     <p:sldId id="268" r:id="rId11"/>
     <p:sldId id="269" r:id="rId12"/>
@@ -8819,6 +8822,1696 @@
     <mc:Fallback>
       <p:transition spd="med">
         <p:fade/>
+      </p:transition>
+    </mc:Fallback>
+  </mc:AlternateContent>
+</p:sld>
+</file>
+
+<file path=ppt/slides/slide14.xml><?xml version="1.0" encoding="utf-8"?>
+<p:sld xmlns:a="http://schemas.openxmlformats.org/drawingml/2006/main" xmlns:p="http://schemas.openxmlformats.org/presentationml/2006/main" xmlns:r="http://schemas.openxmlformats.org/officeDocument/2006/relationships">
+  <p:cSld>
+    <p:spTree>
+      <p:nvGrpSpPr>
+        <p:cNvPr id="1" name=""/>
+        <p:cNvGrpSpPr/>
+        <p:nvPr/>
+      </p:nvGrpSpPr>
+      <p:grpSpPr/>
+      <p:sp>
+        <p:nvSpPr>
+          <p:cNvPr id="2" name="Title 1"/>
+          <p:cNvSpPr>
+            <a:spLocks noGrp="1"/>
+          </p:cNvSpPr>
+          <p:nvPr>
+            <p:ph type="title"/>
+          </p:nvPr>
+        </p:nvSpPr>
+        <p:spPr>
+          <a:xfrm>
+            <a:off x="841248" y="548640"/>
+            <a:ext cx="10515600" cy="868680"/>
+          </a:xfrm>
+        </p:spPr>
+        <p:txBody>
+          <a:bodyPr anchor="ctr"/>
+          <a:lstStyle/>
+          <a:p>
+            <a:r>
+              <a:rPr sz="4000" b="1" i="0">
+                <a:solidFill>
+                  <a:srgbClr val="222222"/>
+                </a:solidFill>
+                <a:latin typeface="Arial"/>
+              </a:rPr>
+              <a:t>Same epoch, four images</a:t>
+            </a:r>
+          </a:p>
+        </p:txBody>
+      </p:sp>
+      <p:grpSp>
+        <p:nvGrpSpPr>
+          <p:cNvPr id="5" name="Group 4">
+            <a:extLst>
+              <a:ext uri="{FF2B5EF4-FFF2-40B4-BE49-F238E27FC236}">
+                <a16:creationId xmlns:a16="http://schemas.microsoft.com/office/drawing/2014/main" id="{DD61A49B-2A57-9774-88AA-46117D53DEE4}"/>
+              </a:ext>
+            </a:extLst>
+          </p:cNvPr>
+          <p:cNvGrpSpPr/>
+          <p:nvPr/>
+        </p:nvGrpSpPr>
+        <p:grpSpPr>
+          <a:xfrm>
+            <a:off x="285674" y="30506"/>
+            <a:ext cx="11701900" cy="480834"/>
+            <a:chOff x="285674" y="30506"/>
+            <a:chExt cx="11701900" cy="480834"/>
+          </a:xfrm>
+        </p:grpSpPr>
+        <p:sp>
+          <p:nvSpPr>
+            <p:cNvPr id="6" name="TextBox 5">
+              <a:extLst>
+                <a:ext uri="{FF2B5EF4-FFF2-40B4-BE49-F238E27FC236}">
+                  <a16:creationId xmlns:a16="http://schemas.microsoft.com/office/drawing/2014/main" id="{7C9A7A8A-4F4A-E934-FAAA-1305669F46EC}"/>
+                </a:ext>
+              </a:extLst>
+            </p:cNvPr>
+            <p:cNvSpPr txBox="1"/>
+            <p:nvPr/>
+          </p:nvSpPr>
+          <p:spPr>
+            <a:xfrm>
+              <a:off x="285674" y="145223"/>
+              <a:ext cx="6982825" cy="338554"/>
+            </a:xfrm>
+            <a:prstGeom prst="rect">
+              <a:avLst/>
+            </a:prstGeom>
+            <a:noFill/>
+          </p:spPr>
+          <p:txBody>
+            <a:bodyPr wrap="square">
+              <a:spAutoFit/>
+            </a:bodyPr>
+            <a:lstStyle/>
+            <a:p>
+              <a:r>
+                <a:rPr lang="en-US" sz="1600" dirty="0">
+                  <a:latin typeface="Arial" panose="020B0604020202020204" pitchFamily="34" charset="0"/>
+                  <a:cs typeface="Arial" panose="020B0604020202020204" pitchFamily="34" charset="0"/>
+                </a:rPr>
+                <a:t>BioMed Frontiers 2026 | International Conference on Biomedical Innovation</a:t>
+              </a:r>
+              <a:endParaRPr lang="en-US" sz="1600" dirty="0"/>
+            </a:p>
+          </p:txBody>
+        </p:sp>
+        <p:pic>
+          <p:nvPicPr>
+            <p:cNvPr id="7" name="Picture 6">
+              <a:extLst>
+                <a:ext uri="{FF2B5EF4-FFF2-40B4-BE49-F238E27FC236}">
+                  <a16:creationId xmlns:a16="http://schemas.microsoft.com/office/drawing/2014/main" id="{330C2F2A-83C9-29D7-D322-09CA5A630AB6}"/>
+                </a:ext>
+              </a:extLst>
+            </p:cNvPr>
+            <p:cNvPicPr>
+              <a:picLocks noChangeAspect="1"/>
+            </p:cNvPicPr>
+            <p:nvPr/>
+          </p:nvPicPr>
+          <p:blipFill>
+            <a:blip r:embed="rId2"/>
+            <a:stretch>
+              <a:fillRect/>
+            </a:stretch>
+          </p:blipFill>
+          <p:spPr>
+            <a:xfrm>
+              <a:off x="10593851" y="30506"/>
+              <a:ext cx="1393723" cy="480834"/>
+            </a:xfrm>
+            <a:prstGeom prst="rect">
+              <a:avLst/>
+            </a:prstGeom>
+          </p:spPr>
+        </p:pic>
+      </p:grpSp>
+      <p:sp>
+        <p:nvSpPr>
+          <p:cNvPr id="4" name="Slide Number Placeholder 3">
+            <a:extLst>
+              <a:ext uri="{FF2B5EF4-FFF2-40B4-BE49-F238E27FC236}">
+                <a16:creationId xmlns:a16="http://schemas.microsoft.com/office/drawing/2014/main" id="{4A408C85-B377-2DB1-EF8F-00D922D8FA43}"/>
+              </a:ext>
+            </a:extLst>
+          </p:cNvPr>
+          <p:cNvSpPr>
+            <a:spLocks noGrp="1"/>
+          </p:cNvSpPr>
+          <p:nvPr>
+            <p:ph type="sldNum" sz="quarter" idx="12"/>
+          </p:nvPr>
+        </p:nvSpPr>
+        <p:spPr/>
+        <p:txBody>
+          <a:bodyPr/>
+          <a:lstStyle/>
+          <a:p>
+            <a:fld id="{7F469C41-6B9F-4AAA-9F31-D78B57F455E2}" type="slidenum">
+              <a:rPr lang="en-GB" smtClean="0"/>
+              <a:t>6</a:t>
+            </a:fld>
+            <a:endParaRPr lang="en-GB"/>
+          </a:p>
+        </p:txBody>
+      </p:sp>
+      <p:sp>
+        <p:nvSpPr>
+          <p:cNvPr id="14" name="Method card"/>
+          <p:cNvSpPr/>
+          <p:nvPr/>
+        </p:nvSpPr>
+        <p:spPr>
+          <a:xfrm>
+            <a:off x="841248" y="1554480"/>
+            <a:ext cx="10515600" cy="3900000"/>
+          </a:xfrm>
+          <a:prstGeom prst="roundRect">
+            <a:avLst>
+              <a:gd name="adj" fmla="val 6000"/>
+            </a:avLst>
+          </a:prstGeom>
+          <a:solidFill>
+            <a:srgbClr val="F1E9F7"/>
+          </a:solidFill>
+          <a:ln>
+            <a:noFill/>
+          </a:ln>
+          <a:effectLst/>
+        </p:spPr>
+        <p:style>
+          <a:lnRef idx="1">
+            <a:schemeClr val="accent1"/>
+          </a:lnRef>
+          <a:fillRef idx="3">
+            <a:schemeClr val="accent1"/>
+          </a:fillRef>
+          <a:effectRef idx="2">
+            <a:schemeClr val="accent1"/>
+          </a:effectRef>
+          <a:fontRef idx="minor">
+            <a:schemeClr val="lt1"/>
+          </a:fontRef>
+        </p:style>
+        <p:txBody>
+          <a:bodyPr rtlCol="0" anchor="ctr"/>
+          <a:lstStyle/>
+          <a:p>
+            <a:pPr algn="ctr"/>
+            <a:endParaRPr/>
+          </a:p>
+        </p:txBody>
+      </p:sp>
+      <p:sp>
+        <p:nvSpPr>
+          <p:cNvPr id="13" name="TextBox 12"/>
+          <p:cNvSpPr txBox="1"/>
+          <p:nvPr/>
+        </p:nvSpPr>
+        <p:spPr>
+          <a:xfrm>
+            <a:off x="941248" y="1640000"/>
+            <a:ext cx="10315600" cy="380000"/>
+          </a:xfrm>
+          <a:prstGeom prst="rect">
+            <a:avLst/>
+          </a:prstGeom>
+          <a:noFill/>
+        </p:spPr>
+        <p:txBody>
+          <a:bodyPr wrap="none" lIns="45720" tIns="27432" rIns="45720" bIns="27432" anchor="t">
+            <a:spAutoFit/>
+          </a:bodyPr>
+          <a:lstStyle/>
+          <a:p>
+            <a:pPr algn="ctr">
+              <a:spcAft>
+                <a:spcPts val="600"/>
+              </a:spcAft>
+            </a:pPr>
+            <a:r>
+              <a:rPr sz="1400" b="0" i="0">
+                <a:solidFill>
+                  <a:srgbClr val="222222"/>
+                </a:solidFill>
+                <a:latin typeface="Arial"/>
+              </a:rPr>
+              <a:t>One subject, one 30 s epoch, original 512 Hz: 16 channels tiled into a 4×4 composite</a:t>
+            </a:r>
+          </a:p>
+        </p:txBody>
+      </p:sp>
+      <p:pic>
+        <p:nvPicPr>
+          <p:cNvPr id="15" name="Picture 14" descr="ts2img.png"/>
+          <p:cNvPicPr>
+            <a:picLocks noChangeAspect="1"/>
+          </p:cNvPicPr>
+          <p:nvPr/>
+        </p:nvPicPr>
+        <p:blipFill>
+          <a:blip r:embed="rId3"/>
+          <a:stretch>
+            <a:fillRect/>
+          </a:stretch>
+        </p:blipFill>
+        <p:spPr>
+          <a:xfrm>
+            <a:off x="1041248" y="2080000"/>
+            <a:ext cx="10115600" cy="2747972"/>
+          </a:xfrm>
+          <a:prstGeom prst="rect">
+            <a:avLst/>
+          </a:prstGeom>
+        </p:spPr>
+      </p:pic>
+      <p:sp>
+        <p:nvSpPr>
+          <p:cNvPr id="13" name="TextBox 12"/>
+          <p:cNvSpPr txBox="1"/>
+          <p:nvPr/>
+        </p:nvSpPr>
+        <p:spPr>
+          <a:xfrm>
+            <a:off x="1041248" y="4887972"/>
+            <a:ext cx="2528900" cy="380000"/>
+          </a:xfrm>
+          <a:prstGeom prst="rect">
+            <a:avLst/>
+          </a:prstGeom>
+          <a:noFill/>
+        </p:spPr>
+        <p:txBody>
+          <a:bodyPr wrap="none" lIns="45720" tIns="27432" rIns="45720" bIns="27432" anchor="t">
+            <a:spAutoFit/>
+          </a:bodyPr>
+          <a:lstStyle/>
+          <a:p>
+            <a:pPr algn="ctr">
+              <a:spcAft>
+                <a:spcPts val="600"/>
+              </a:spcAft>
+            </a:pPr>
+            <a:r>
+              <a:rPr sz="1400" b="1" i="0">
+                <a:solidFill>
+                  <a:srgbClr val="222222"/>
+                </a:solidFill>
+                <a:latin typeface="Arial"/>
+              </a:rPr>
+              <a:t>Angle difference</a:t>
+            </a:r>
+          </a:p>
+        </p:txBody>
+      </p:sp>
+      <p:sp>
+        <p:nvSpPr>
+          <p:cNvPr id="13" name="TextBox 12"/>
+          <p:cNvSpPr txBox="1"/>
+          <p:nvPr/>
+        </p:nvSpPr>
+        <p:spPr>
+          <a:xfrm>
+            <a:off x="3570148" y="4887972"/>
+            <a:ext cx="2528900" cy="380000"/>
+          </a:xfrm>
+          <a:prstGeom prst="rect">
+            <a:avLst/>
+          </a:prstGeom>
+          <a:noFill/>
+        </p:spPr>
+        <p:txBody>
+          <a:bodyPr wrap="none" lIns="45720" tIns="27432" rIns="45720" bIns="27432" anchor="t">
+            <a:spAutoFit/>
+          </a:bodyPr>
+          <a:lstStyle/>
+          <a:p>
+            <a:pPr algn="ctr">
+              <a:spcAft>
+                <a:spcPts val="600"/>
+              </a:spcAft>
+            </a:pPr>
+            <a:r>
+              <a:rPr sz="1400" b="1" i="0">
+                <a:solidFill>
+                  <a:srgbClr val="222222"/>
+                </a:solidFill>
+                <a:latin typeface="Arial"/>
+              </a:rPr>
+              <a:t>Angle sum</a:t>
+            </a:r>
+          </a:p>
+        </p:txBody>
+      </p:sp>
+      <p:sp>
+        <p:nvSpPr>
+          <p:cNvPr id="13" name="TextBox 12"/>
+          <p:cNvSpPr txBox="1"/>
+          <p:nvPr/>
+        </p:nvSpPr>
+        <p:spPr>
+          <a:xfrm>
+            <a:off x="6099048" y="4887972"/>
+            <a:ext cx="2528900" cy="380000"/>
+          </a:xfrm>
+          <a:prstGeom prst="rect">
+            <a:avLst/>
+          </a:prstGeom>
+          <a:noFill/>
+        </p:spPr>
+        <p:txBody>
+          <a:bodyPr wrap="none" lIns="45720" tIns="27432" rIns="45720" bIns="27432" anchor="t">
+            <a:spAutoFit/>
+          </a:bodyPr>
+          <a:lstStyle/>
+          <a:p>
+            <a:pPr algn="ctr">
+              <a:spcAft>
+                <a:spcPts val="600"/>
+              </a:spcAft>
+            </a:pPr>
+            <a:r>
+              <a:rPr sz="1400" b="1" i="0">
+                <a:solidFill>
+                  <a:srgbClr val="222222"/>
+                </a:solidFill>
+                <a:latin typeface="Arial"/>
+              </a:rPr>
+              <a:t>Time–frequency (STFT)</a:t>
+            </a:r>
+          </a:p>
+        </p:txBody>
+      </p:sp>
+      <p:sp>
+        <p:nvSpPr>
+          <p:cNvPr id="13" name="TextBox 12"/>
+          <p:cNvSpPr txBox="1"/>
+          <p:nvPr/>
+        </p:nvSpPr>
+        <p:spPr>
+          <a:xfrm>
+            <a:off x="8627948" y="4887972"/>
+            <a:ext cx="2528900" cy="380000"/>
+          </a:xfrm>
+          <a:prstGeom prst="rect">
+            <a:avLst/>
+          </a:prstGeom>
+          <a:noFill/>
+        </p:spPr>
+        <p:txBody>
+          <a:bodyPr wrap="none" lIns="45720" tIns="27432" rIns="45720" bIns="27432" anchor="t">
+            <a:spAutoFit/>
+          </a:bodyPr>
+          <a:lstStyle/>
+          <a:p>
+            <a:pPr algn="ctr">
+              <a:spcAft>
+                <a:spcPts val="600"/>
+              </a:spcAft>
+            </a:pPr>
+            <a:r>
+              <a:rPr sz="1400" b="1" i="0">
+                <a:solidFill>
+                  <a:srgbClr val="222222"/>
+                </a:solidFill>
+                <a:latin typeface="Arial"/>
+              </a:rPr>
+              <a:t>Transition probabilities</a:t>
+            </a:r>
+          </a:p>
+        </p:txBody>
+      </p:sp>
+      <p:sp>
+        <p:nvSpPr>
+          <p:cNvPr id="32" name="Takeaway card"/>
+          <p:cNvSpPr/>
+          <p:nvPr/>
+        </p:nvSpPr>
+        <p:spPr>
+          <a:xfrm>
+            <a:off x="841248" y="5760720"/>
+            <a:ext cx="10515600" cy="548640"/>
+          </a:xfrm>
+          <a:prstGeom prst="roundRect">
+            <a:avLst>
+              <a:gd name="adj" fmla="val 6000"/>
+            </a:avLst>
+          </a:prstGeom>
+          <a:solidFill>
+            <a:srgbClr val="6A2C91"/>
+          </a:solidFill>
+          <a:ln>
+            <a:noFill/>
+          </a:ln>
+          <a:effectLst/>
+        </p:spPr>
+        <p:style>
+          <a:lnRef idx="1">
+            <a:schemeClr val="accent1"/>
+          </a:lnRef>
+          <a:fillRef idx="3">
+            <a:schemeClr val="accent1"/>
+          </a:fillRef>
+          <a:effectRef idx="2">
+            <a:schemeClr val="accent1"/>
+          </a:effectRef>
+          <a:fontRef idx="minor">
+            <a:schemeClr val="lt1"/>
+          </a:fontRef>
+        </p:style>
+        <p:txBody>
+          <a:bodyPr rtlCol="0" anchor="ctr"/>
+          <a:lstStyle/>
+          <a:p>
+            <a:pPr algn="ctr"/>
+            <a:endParaRPr/>
+          </a:p>
+        </p:txBody>
+      </p:sp>
+      <p:pic>
+        <p:nvPicPr>
+          <p:cNvPr id="33" name="Picture 32" descr="image.png"/>
+          <p:cNvPicPr>
+            <a:picLocks noChangeAspect="1"/>
+          </p:cNvPicPr>
+          <p:nvPr/>
+        </p:nvPicPr>
+        <p:blipFill>
+          <a:blip r:embed="rId4"/>
+          <a:stretch>
+            <a:fillRect/>
+          </a:stretch>
+        </p:blipFill>
+        <p:spPr>
+          <a:xfrm>
+            <a:off x="1069848" y="5870448"/>
+            <a:ext cx="329184" cy="329184"/>
+          </a:xfrm>
+          <a:prstGeom prst="rect">
+            <a:avLst/>
+          </a:prstGeom>
+        </p:spPr>
+      </p:pic>
+      <p:sp>
+        <p:nvSpPr>
+          <p:cNvPr id="34" name="Takeaway"/>
+          <p:cNvSpPr txBox="1"/>
+          <p:nvPr/>
+        </p:nvSpPr>
+        <p:spPr>
+          <a:xfrm>
+            <a:off x="1508760" y="5760720"/>
+            <a:ext cx="9601200" cy="548640"/>
+          </a:xfrm>
+          <a:prstGeom prst="rect">
+            <a:avLst/>
+          </a:prstGeom>
+          <a:noFill/>
+        </p:spPr>
+        <p:txBody>
+          <a:bodyPr wrap="square" lIns="45720" tIns="27432" rIns="45720" bIns="27432" anchor="ctr">
+            <a:spAutoFit/>
+          </a:bodyPr>
+          <a:lstStyle/>
+          <a:p>
+            <a:pPr algn="l">
+              <a:spcAft>
+                <a:spcPts val="600"/>
+              </a:spcAft>
+            </a:pPr>
+            <a:r>
+              <a:rPr sz="2000" b="1" i="0">
+                <a:solidFill>
+                  <a:srgbClr val="FFFFFF"/>
+                </a:solidFill>
+                <a:latin typeface="Arial"/>
+              </a:rPr>
+              <a:t>The encoding changes the texture the ViT sees; GASF keeps rich structure</a:t>
+            </a:r>
+          </a:p>
+        </p:txBody>
+      </p:sp>
+    </p:spTree>
+  </p:cSld>
+  <p:clrMapOvr>
+    <a:masterClrMapping/>
+  </p:clrMapOvr>
+  <mc:AlternateContent xmlns:mc="http://schemas.openxmlformats.org/markup-compatibility/2006">
+    <mc:Choice xmlns:p14="http://schemas.microsoft.com/office/powerpoint/2010/main" Requires="p14">
+      <p:transition spd="med" p14:dur="700">
+        <p:push dir="l"/>
+      </p:transition>
+    </mc:Choice>
+    <mc:Fallback>
+      <p:transition spd="med">
+        <p:push dir="l"/>
+      </p:transition>
+    </mc:Fallback>
+  </mc:AlternateContent>
+</p:sld>
+</file>
+
+<file path=ppt/slides/slide15.xml><?xml version="1.0" encoding="utf-8"?>
+<p:sld xmlns:a="http://schemas.openxmlformats.org/drawingml/2006/main" xmlns:p="http://schemas.openxmlformats.org/presentationml/2006/main" xmlns:r="http://schemas.openxmlformats.org/officeDocument/2006/relationships">
+  <p:cSld>
+    <p:spTree>
+      <p:nvGrpSpPr>
+        <p:cNvPr id="1" name=""/>
+        <p:cNvGrpSpPr/>
+        <p:nvPr/>
+      </p:nvGrpSpPr>
+      <p:grpSpPr/>
+      <p:sp>
+        <p:nvSpPr>
+          <p:cNvPr id="2" name="Title 1"/>
+          <p:cNvSpPr>
+            <a:spLocks noGrp="1"/>
+          </p:cNvSpPr>
+          <p:nvPr>
+            <p:ph type="title"/>
+          </p:nvPr>
+        </p:nvSpPr>
+        <p:spPr>
+          <a:xfrm>
+            <a:off x="841248" y="548640"/>
+            <a:ext cx="10515600" cy="868680"/>
+          </a:xfrm>
+        </p:spPr>
+        <p:txBody>
+          <a:bodyPr anchor="ctr"/>
+          <a:lstStyle/>
+          <a:p>
+            <a:r>
+              <a:rPr sz="4000" b="1" i="0">
+                <a:solidFill>
+                  <a:srgbClr val="222222"/>
+                </a:solidFill>
+                <a:latin typeface="Arial"/>
+              </a:rPr>
+              <a:t>Downsampling: FFT vs DWT</a:t>
+            </a:r>
+          </a:p>
+        </p:txBody>
+      </p:sp>
+      <p:grpSp>
+        <p:nvGrpSpPr>
+          <p:cNvPr id="5" name="Group 4">
+            <a:extLst>
+              <a:ext uri="{FF2B5EF4-FFF2-40B4-BE49-F238E27FC236}">
+                <a16:creationId xmlns:a16="http://schemas.microsoft.com/office/drawing/2014/main" id="{DD61A49B-2A57-9774-88AA-46117D53DEE4}"/>
+              </a:ext>
+            </a:extLst>
+          </p:cNvPr>
+          <p:cNvGrpSpPr/>
+          <p:nvPr/>
+        </p:nvGrpSpPr>
+        <p:grpSpPr>
+          <a:xfrm>
+            <a:off x="285674" y="30506"/>
+            <a:ext cx="11701900" cy="480834"/>
+            <a:chOff x="285674" y="30506"/>
+            <a:chExt cx="11701900" cy="480834"/>
+          </a:xfrm>
+        </p:grpSpPr>
+        <p:sp>
+          <p:nvSpPr>
+            <p:cNvPr id="6" name="TextBox 5">
+              <a:extLst>
+                <a:ext uri="{FF2B5EF4-FFF2-40B4-BE49-F238E27FC236}">
+                  <a16:creationId xmlns:a16="http://schemas.microsoft.com/office/drawing/2014/main" id="{7C9A7A8A-4F4A-E934-FAAA-1305669F46EC}"/>
+                </a:ext>
+              </a:extLst>
+            </p:cNvPr>
+            <p:cNvSpPr txBox="1"/>
+            <p:nvPr/>
+          </p:nvSpPr>
+          <p:spPr>
+            <a:xfrm>
+              <a:off x="285674" y="145223"/>
+              <a:ext cx="6982825" cy="338554"/>
+            </a:xfrm>
+            <a:prstGeom prst="rect">
+              <a:avLst/>
+            </a:prstGeom>
+            <a:noFill/>
+          </p:spPr>
+          <p:txBody>
+            <a:bodyPr wrap="square">
+              <a:spAutoFit/>
+            </a:bodyPr>
+            <a:lstStyle/>
+            <a:p>
+              <a:r>
+                <a:rPr lang="en-US" sz="1600" dirty="0">
+                  <a:latin typeface="Arial" panose="020B0604020202020204" pitchFamily="34" charset="0"/>
+                  <a:cs typeface="Arial" panose="020B0604020202020204" pitchFamily="34" charset="0"/>
+                </a:rPr>
+                <a:t>BioMed Frontiers 2026 | International Conference on Biomedical Innovation</a:t>
+              </a:r>
+              <a:endParaRPr lang="en-US" sz="1600" dirty="0"/>
+            </a:p>
+          </p:txBody>
+        </p:sp>
+        <p:pic>
+          <p:nvPicPr>
+            <p:cNvPr id="7" name="Picture 6">
+              <a:extLst>
+                <a:ext uri="{FF2B5EF4-FFF2-40B4-BE49-F238E27FC236}">
+                  <a16:creationId xmlns:a16="http://schemas.microsoft.com/office/drawing/2014/main" id="{330C2F2A-83C9-29D7-D322-09CA5A630AB6}"/>
+                </a:ext>
+              </a:extLst>
+            </p:cNvPr>
+            <p:cNvPicPr>
+              <a:picLocks noChangeAspect="1"/>
+            </p:cNvPicPr>
+            <p:nvPr/>
+          </p:nvPicPr>
+          <p:blipFill>
+            <a:blip r:embed="rId2"/>
+            <a:stretch>
+              <a:fillRect/>
+            </a:stretch>
+          </p:blipFill>
+          <p:spPr>
+            <a:xfrm>
+              <a:off x="10593851" y="30506"/>
+              <a:ext cx="1393723" cy="480834"/>
+            </a:xfrm>
+            <a:prstGeom prst="rect">
+              <a:avLst/>
+            </a:prstGeom>
+          </p:spPr>
+        </p:pic>
+      </p:grpSp>
+      <p:sp>
+        <p:nvSpPr>
+          <p:cNvPr id="4" name="Slide Number Placeholder 3">
+            <a:extLst>
+              <a:ext uri="{FF2B5EF4-FFF2-40B4-BE49-F238E27FC236}">
+                <a16:creationId xmlns:a16="http://schemas.microsoft.com/office/drawing/2014/main" id="{4A408C85-B377-2DB1-EF8F-00D922D8FA43}"/>
+              </a:ext>
+            </a:extLst>
+          </p:cNvPr>
+          <p:cNvSpPr>
+            <a:spLocks noGrp="1"/>
+          </p:cNvSpPr>
+          <p:nvPr>
+            <p:ph type="sldNum" sz="quarter" idx="12"/>
+          </p:nvPr>
+        </p:nvSpPr>
+        <p:spPr/>
+        <p:txBody>
+          <a:bodyPr/>
+          <a:lstStyle/>
+          <a:p>
+            <a:fld id="{7F469C41-6B9F-4AAA-9F31-D78B57F455E2}" type="slidenum">
+              <a:rPr lang="en-GB" smtClean="0"/>
+              <a:t>6</a:t>
+            </a:fld>
+            <a:endParaRPr lang="en-GB"/>
+          </a:p>
+        </p:txBody>
+      </p:sp>
+      <p:sp>
+        <p:nvSpPr>
+          <p:cNvPr id="14" name="Method card"/>
+          <p:cNvSpPr/>
+          <p:nvPr/>
+        </p:nvSpPr>
+        <p:spPr>
+          <a:xfrm>
+            <a:off x="841248" y="1554480"/>
+            <a:ext cx="7000000" cy="4050000"/>
+          </a:xfrm>
+          <a:prstGeom prst="roundRect">
+            <a:avLst>
+              <a:gd name="adj" fmla="val 6000"/>
+            </a:avLst>
+          </a:prstGeom>
+          <a:solidFill>
+            <a:srgbClr val="F1E9F7"/>
+          </a:solidFill>
+          <a:ln>
+            <a:noFill/>
+          </a:ln>
+          <a:effectLst/>
+        </p:spPr>
+        <p:style>
+          <a:lnRef idx="1">
+            <a:schemeClr val="accent1"/>
+          </a:lnRef>
+          <a:fillRef idx="3">
+            <a:schemeClr val="accent1"/>
+          </a:fillRef>
+          <a:effectRef idx="2">
+            <a:schemeClr val="accent1"/>
+          </a:effectRef>
+          <a:fontRef idx="minor">
+            <a:schemeClr val="lt1"/>
+          </a:fontRef>
+        </p:style>
+        <p:txBody>
+          <a:bodyPr rtlCol="0" anchor="ctr"/>
+          <a:lstStyle/>
+          <a:p>
+            <a:pPr algn="ctr"/>
+            <a:endParaRPr/>
+          </a:p>
+        </p:txBody>
+      </p:sp>
+      <p:pic>
+        <p:nvPicPr>
+          <p:cNvPr id="15" name="Picture 14" descr="fft.png"/>
+          <p:cNvPicPr>
+            <a:picLocks noChangeAspect="1"/>
+          </p:cNvPicPr>
+          <p:nvPr/>
+        </p:nvPicPr>
+        <p:blipFill>
+          <a:blip r:embed="rId3"/>
+          <a:stretch>
+            <a:fillRect/>
+          </a:stretch>
+        </p:blipFill>
+        <p:spPr>
+          <a:xfrm>
+            <a:off x="1601248" y="1680000"/>
+            <a:ext cx="6100000" cy="1657106"/>
+          </a:xfrm>
+          <a:prstGeom prst="rect">
+            <a:avLst/>
+          </a:prstGeom>
+        </p:spPr>
+      </p:pic>
+      <p:pic>
+        <p:nvPicPr>
+          <p:cNvPr id="16" name="Picture 15" descr="dwt.png"/>
+          <p:cNvPicPr>
+            <a:picLocks noChangeAspect="1"/>
+          </p:cNvPicPr>
+          <p:nvPr/>
+        </p:nvPicPr>
+        <p:blipFill>
+          <a:blip r:embed="rId4"/>
+          <a:stretch>
+            <a:fillRect/>
+          </a:stretch>
+        </p:blipFill>
+        <p:spPr>
+          <a:xfrm>
+            <a:off x="1601248" y="3487106"/>
+            <a:ext cx="6100000" cy="1657106"/>
+          </a:xfrm>
+          <a:prstGeom prst="rect">
+            <a:avLst/>
+          </a:prstGeom>
+        </p:spPr>
+      </p:pic>
+      <p:sp>
+        <p:nvSpPr>
+          <p:cNvPr id="13" name="TextBox 12"/>
+          <p:cNvSpPr txBox="1"/>
+          <p:nvPr/>
+        </p:nvSpPr>
+        <p:spPr>
+          <a:xfrm>
+            <a:off x="921248" y="2318553"/>
+            <a:ext cx="680000" cy="380000"/>
+          </a:xfrm>
+          <a:prstGeom prst="rect">
+            <a:avLst/>
+          </a:prstGeom>
+          <a:noFill/>
+        </p:spPr>
+        <p:txBody>
+          <a:bodyPr wrap="none" lIns="45720" tIns="27432" rIns="45720" bIns="27432" anchor="t">
+            <a:spAutoFit/>
+          </a:bodyPr>
+          <a:lstStyle/>
+          <a:p>
+            <a:pPr algn="ctr">
+              <a:spcAft>
+                <a:spcPts val="600"/>
+              </a:spcAft>
+            </a:pPr>
+            <a:r>
+              <a:rPr sz="1600" b="1" i="0">
+                <a:solidFill>
+                  <a:srgbClr val="222222"/>
+                </a:solidFill>
+                <a:latin typeface="Arial"/>
+              </a:rPr>
+              <a:t>FFT</a:t>
+            </a:r>
+          </a:p>
+        </p:txBody>
+      </p:sp>
+      <p:sp>
+        <p:nvSpPr>
+          <p:cNvPr id="13" name="TextBox 12"/>
+          <p:cNvSpPr txBox="1"/>
+          <p:nvPr/>
+        </p:nvSpPr>
+        <p:spPr>
+          <a:xfrm>
+            <a:off x="921248" y="4125659"/>
+            <a:ext cx="680000" cy="380000"/>
+          </a:xfrm>
+          <a:prstGeom prst="rect">
+            <a:avLst/>
+          </a:prstGeom>
+          <a:noFill/>
+        </p:spPr>
+        <p:txBody>
+          <a:bodyPr wrap="none" lIns="45720" tIns="27432" rIns="45720" bIns="27432" anchor="t">
+            <a:spAutoFit/>
+          </a:bodyPr>
+          <a:lstStyle/>
+          <a:p>
+            <a:pPr algn="ctr">
+              <a:spcAft>
+                <a:spcPts val="600"/>
+              </a:spcAft>
+            </a:pPr>
+            <a:r>
+              <a:rPr sz="1600" b="1" i="0">
+                <a:solidFill>
+                  <a:srgbClr val="222222"/>
+                </a:solidFill>
+                <a:latin typeface="Arial"/>
+              </a:rPr>
+              <a:t>DWT</a:t>
+            </a:r>
+          </a:p>
+        </p:txBody>
+      </p:sp>
+      <p:sp>
+        <p:nvSpPr>
+          <p:cNvPr id="15" name="Stat card"/>
+          <p:cNvSpPr/>
+          <p:nvPr/>
+        </p:nvSpPr>
+        <p:spPr>
+          <a:xfrm>
+            <a:off x="8238160" y="1645920"/>
+            <a:ext cx="3118840" cy="4000000"/>
+          </a:xfrm>
+          <a:prstGeom prst="roundRect">
+            <a:avLst>
+              <a:gd name="adj" fmla="val 6000"/>
+            </a:avLst>
+          </a:prstGeom>
+          <a:solidFill>
+            <a:srgbClr val="6A2C91"/>
+          </a:solidFill>
+          <a:ln>
+            <a:noFill/>
+          </a:ln>
+          <a:effectLst/>
+        </p:spPr>
+        <p:style>
+          <a:lnRef idx="1">
+            <a:schemeClr val="accent1"/>
+          </a:lnRef>
+          <a:fillRef idx="3">
+            <a:schemeClr val="accent1"/>
+          </a:fillRef>
+          <a:effectRef idx="2">
+            <a:schemeClr val="accent1"/>
+          </a:effectRef>
+          <a:fontRef idx="minor">
+            <a:schemeClr val="lt1"/>
+          </a:fontRef>
+        </p:style>
+        <p:txBody>
+          <a:bodyPr rtlCol="0" anchor="ctr"/>
+          <a:lstStyle/>
+          <a:p>
+            <a:pPr algn="ctr"/>
+            <a:endParaRPr/>
+          </a:p>
+        </p:txBody>
+      </p:sp>
+      <p:sp>
+        <p:nvSpPr>
+          <p:cNvPr id="17" name="Stat label"/>
+          <p:cNvSpPr txBox="1"/>
+          <p:nvPr/>
+        </p:nvSpPr>
+        <p:spPr>
+          <a:xfrm>
+            <a:off x="8318160" y="1750000"/>
+            <a:ext cx="3000000" cy="3700000"/>
+          </a:xfrm>
+          <a:prstGeom prst="rect">
+            <a:avLst/>
+          </a:prstGeom>
+          <a:noFill/>
+        </p:spPr>
+        <p:txBody>
+          <a:bodyPr wrap="square" lIns="45720" tIns="27432" rIns="45720" bIns="27432" anchor="t">
+            <a:spAutoFit/>
+          </a:bodyPr>
+          <a:lstStyle/>
+          <a:p>
+            <a:pPr algn="l">
+              <a:spcAft>
+                <a:spcPts val="1000"/>
+              </a:spcAft>
+            </a:pPr>
+            <a:r>
+              <a:rPr sz="2000" b="1" i="0">
+                <a:solidFill>
+                  <a:srgbClr val="FFFFFF"/>
+                </a:solidFill>
+                <a:latin typeface="Arial"/>
+              </a:rPr>
+              <a:t>What to look for</a:t>
+            </a:r>
+          </a:p>
+          <a:p>
+            <a:pPr algn="l">
+              <a:spcAft>
+                <a:spcPts val="1000"/>
+              </a:spcAft>
+            </a:pPr>
+            <a:r>
+              <a:rPr sz="1500" b="0" i="0">
+                <a:solidFill>
+                  <a:srgbClr val="FFFFFF"/>
+                </a:solidFill>
+                <a:latin typeface="Arial"/>
+              </a:rPr>
+              <a:t>GASF images of the same epoch, resampled to 64, 128, 256 Hz and the 512 Hz original.</a:t>
+            </a:r>
+          </a:p>
+          <a:p>
+            <a:pPr algn="l">
+              <a:spcAft>
+                <a:spcPts val="1000"/>
+              </a:spcAft>
+            </a:pPr>
+            <a:r>
+              <a:rPr sz="1500" b="0" i="0">
+                <a:solidFill>
+                  <a:srgbClr val="FFFFFF"/>
+                </a:solidFill>
+                <a:latin typeface="Arial"/>
+              </a:rPr>
+              <a:t>FFT: image structure stays almost the same at every rate.</a:t>
+            </a:r>
+          </a:p>
+          <a:p>
+            <a:pPr algn="l">
+              <a:spcAft>
+                <a:spcPts val="1000"/>
+              </a:spcAft>
+            </a:pPr>
+            <a:r>
+              <a:rPr sz="1500" b="0" i="0">
+                <a:solidFill>
+                  <a:srgbClr val="FFFFFF"/>
+                </a:solidFill>
+                <a:latin typeface="Arial"/>
+              </a:rPr>
+              <a:t>DWT: images change visibly below 256 Hz; 128 Hz is the sweet spot for accuracy (next slide).</a:t>
+            </a:r>
+          </a:p>
+        </p:txBody>
+      </p:sp>
+      <p:sp>
+        <p:nvSpPr>
+          <p:cNvPr id="32" name="Takeaway card"/>
+          <p:cNvSpPr/>
+          <p:nvPr/>
+        </p:nvSpPr>
+        <p:spPr>
+          <a:xfrm>
+            <a:off x="841248" y="5760720"/>
+            <a:ext cx="10515600" cy="548640"/>
+          </a:xfrm>
+          <a:prstGeom prst="roundRect">
+            <a:avLst>
+              <a:gd name="adj" fmla="val 6000"/>
+            </a:avLst>
+          </a:prstGeom>
+          <a:solidFill>
+            <a:srgbClr val="6A2C91"/>
+          </a:solidFill>
+          <a:ln>
+            <a:noFill/>
+          </a:ln>
+          <a:effectLst/>
+        </p:spPr>
+        <p:style>
+          <a:lnRef idx="1">
+            <a:schemeClr val="accent1"/>
+          </a:lnRef>
+          <a:fillRef idx="3">
+            <a:schemeClr val="accent1"/>
+          </a:fillRef>
+          <a:effectRef idx="2">
+            <a:schemeClr val="accent1"/>
+          </a:effectRef>
+          <a:fontRef idx="minor">
+            <a:schemeClr val="lt1"/>
+          </a:fontRef>
+        </p:style>
+        <p:txBody>
+          <a:bodyPr rtlCol="0" anchor="ctr"/>
+          <a:lstStyle/>
+          <a:p>
+            <a:pPr algn="ctr"/>
+            <a:endParaRPr/>
+          </a:p>
+        </p:txBody>
+      </p:sp>
+      <p:pic>
+        <p:nvPicPr>
+          <p:cNvPr id="33" name="Picture 32" descr="image.png"/>
+          <p:cNvPicPr>
+            <a:picLocks noChangeAspect="1"/>
+          </p:cNvPicPr>
+          <p:nvPr/>
+        </p:nvPicPr>
+        <p:blipFill>
+          <a:blip r:embed="rId5"/>
+          <a:stretch>
+            <a:fillRect/>
+          </a:stretch>
+        </p:blipFill>
+        <p:spPr>
+          <a:xfrm>
+            <a:off x="1069848" y="5870448"/>
+            <a:ext cx="329184" cy="329184"/>
+          </a:xfrm>
+          <a:prstGeom prst="rect">
+            <a:avLst/>
+          </a:prstGeom>
+        </p:spPr>
+      </p:pic>
+      <p:sp>
+        <p:nvSpPr>
+          <p:cNvPr id="34" name="Takeaway"/>
+          <p:cNvSpPr txBox="1"/>
+          <p:nvPr/>
+        </p:nvSpPr>
+        <p:spPr>
+          <a:xfrm>
+            <a:off x="1508760" y="5760720"/>
+            <a:ext cx="9601200" cy="548640"/>
+          </a:xfrm>
+          <a:prstGeom prst="rect">
+            <a:avLst/>
+          </a:prstGeom>
+          <a:noFill/>
+        </p:spPr>
+        <p:txBody>
+          <a:bodyPr wrap="square" lIns="45720" tIns="27432" rIns="45720" bIns="27432" anchor="ctr">
+            <a:spAutoFit/>
+          </a:bodyPr>
+          <a:lstStyle/>
+          <a:p>
+            <a:pPr algn="l">
+              <a:spcAft>
+                <a:spcPts val="600"/>
+              </a:spcAft>
+            </a:pPr>
+            <a:r>
+              <a:rPr sz="2000" b="1" i="0">
+                <a:solidFill>
+                  <a:srgbClr val="FFFFFF"/>
+                </a:solidFill>
+                <a:latin typeface="Arial"/>
+              </a:rPr>
+              <a:t>Same epoch, same GASF encoding; only the resampling method differs</a:t>
+            </a:r>
+          </a:p>
+        </p:txBody>
+      </p:sp>
+    </p:spTree>
+  </p:cSld>
+  <p:clrMapOvr>
+    <a:masterClrMapping/>
+  </p:clrMapOvr>
+  <mc:AlternateContent xmlns:mc="http://schemas.openxmlformats.org/markup-compatibility/2006">
+    <mc:Choice xmlns:p14="http://schemas.microsoft.com/office/powerpoint/2010/main" Requires="p14">
+      <p:transition spd="med" p14:dur="700">
+        <p:push dir="l"/>
+      </p:transition>
+    </mc:Choice>
+    <mc:Fallback>
+      <p:transition spd="med">
+        <p:push dir="l"/>
+      </p:transition>
+    </mc:Fallback>
+  </mc:AlternateContent>
+</p:sld>
+</file>
+
+<file path=ppt/slides/slide16.xml><?xml version="1.0" encoding="utf-8"?>
+<p:sld xmlns:a="http://schemas.openxmlformats.org/drawingml/2006/main" xmlns:p="http://schemas.openxmlformats.org/presentationml/2006/main" xmlns:r="http://schemas.openxmlformats.org/officeDocument/2006/relationships">
+  <p:cSld>
+    <p:spTree>
+      <p:nvGrpSpPr>
+        <p:cNvPr id="1" name=""/>
+        <p:cNvGrpSpPr/>
+        <p:nvPr/>
+      </p:nvGrpSpPr>
+      <p:grpSpPr/>
+      <p:sp>
+        <p:nvSpPr>
+          <p:cNvPr id="2" name="Title 1"/>
+          <p:cNvSpPr>
+            <a:spLocks noGrp="1"/>
+          </p:cNvSpPr>
+          <p:nvPr>
+            <p:ph type="title"/>
+          </p:nvPr>
+        </p:nvSpPr>
+        <p:spPr>
+          <a:xfrm>
+            <a:off x="841248" y="548640"/>
+            <a:ext cx="10515600" cy="868680"/>
+          </a:xfrm>
+        </p:spPr>
+        <p:txBody>
+          <a:bodyPr anchor="ctr"/>
+          <a:lstStyle/>
+          <a:p>
+            <a:r>
+              <a:rPr sz="4000" b="1" i="0">
+                <a:solidFill>
+                  <a:srgbClr val="222222"/>
+                </a:solidFill>
+                <a:latin typeface="Arial"/>
+              </a:rPr>
+              <a:t>Class balancing with DCGAN</a:t>
+            </a:r>
+          </a:p>
+        </p:txBody>
+      </p:sp>
+      <p:grpSp>
+        <p:nvGrpSpPr>
+          <p:cNvPr id="5" name="Group 4">
+            <a:extLst>
+              <a:ext uri="{FF2B5EF4-FFF2-40B4-BE49-F238E27FC236}">
+                <a16:creationId xmlns:a16="http://schemas.microsoft.com/office/drawing/2014/main" id="{DD61A49B-2A57-9774-88AA-46117D53DEE4}"/>
+              </a:ext>
+            </a:extLst>
+          </p:cNvPr>
+          <p:cNvGrpSpPr/>
+          <p:nvPr/>
+        </p:nvGrpSpPr>
+        <p:grpSpPr>
+          <a:xfrm>
+            <a:off x="285674" y="30506"/>
+            <a:ext cx="11701900" cy="480834"/>
+            <a:chOff x="285674" y="30506"/>
+            <a:chExt cx="11701900" cy="480834"/>
+          </a:xfrm>
+        </p:grpSpPr>
+        <p:sp>
+          <p:nvSpPr>
+            <p:cNvPr id="6" name="TextBox 5">
+              <a:extLst>
+                <a:ext uri="{FF2B5EF4-FFF2-40B4-BE49-F238E27FC236}">
+                  <a16:creationId xmlns:a16="http://schemas.microsoft.com/office/drawing/2014/main" id="{7C9A7A8A-4F4A-E934-FAAA-1305669F46EC}"/>
+                </a:ext>
+              </a:extLst>
+            </p:cNvPr>
+            <p:cNvSpPr txBox="1"/>
+            <p:nvPr/>
+          </p:nvSpPr>
+          <p:spPr>
+            <a:xfrm>
+              <a:off x="285674" y="145223"/>
+              <a:ext cx="6982825" cy="338554"/>
+            </a:xfrm>
+            <a:prstGeom prst="rect">
+              <a:avLst/>
+            </a:prstGeom>
+            <a:noFill/>
+          </p:spPr>
+          <p:txBody>
+            <a:bodyPr wrap="square">
+              <a:spAutoFit/>
+            </a:bodyPr>
+            <a:lstStyle/>
+            <a:p>
+              <a:r>
+                <a:rPr lang="en-US" sz="1600" dirty="0">
+                  <a:latin typeface="Arial" panose="020B0604020202020204" pitchFamily="34" charset="0"/>
+                  <a:cs typeface="Arial" panose="020B0604020202020204" pitchFamily="34" charset="0"/>
+                </a:rPr>
+                <a:t>BioMed Frontiers 2026 | International Conference on Biomedical Innovation</a:t>
+              </a:r>
+              <a:endParaRPr lang="en-US" sz="1600" dirty="0"/>
+            </a:p>
+          </p:txBody>
+        </p:sp>
+        <p:pic>
+          <p:nvPicPr>
+            <p:cNvPr id="7" name="Picture 6">
+              <a:extLst>
+                <a:ext uri="{FF2B5EF4-FFF2-40B4-BE49-F238E27FC236}">
+                  <a16:creationId xmlns:a16="http://schemas.microsoft.com/office/drawing/2014/main" id="{330C2F2A-83C9-29D7-D322-09CA5A630AB6}"/>
+                </a:ext>
+              </a:extLst>
+            </p:cNvPr>
+            <p:cNvPicPr>
+              <a:picLocks noChangeAspect="1"/>
+            </p:cNvPicPr>
+            <p:nvPr/>
+          </p:nvPicPr>
+          <p:blipFill>
+            <a:blip r:embed="rId2"/>
+            <a:stretch>
+              <a:fillRect/>
+            </a:stretch>
+          </p:blipFill>
+          <p:spPr>
+            <a:xfrm>
+              <a:off x="10593851" y="30506"/>
+              <a:ext cx="1393723" cy="480834"/>
+            </a:xfrm>
+            <a:prstGeom prst="rect">
+              <a:avLst/>
+            </a:prstGeom>
+          </p:spPr>
+        </p:pic>
+      </p:grpSp>
+      <p:sp>
+        <p:nvSpPr>
+          <p:cNvPr id="4" name="Slide Number Placeholder 3">
+            <a:extLst>
+              <a:ext uri="{FF2B5EF4-FFF2-40B4-BE49-F238E27FC236}">
+                <a16:creationId xmlns:a16="http://schemas.microsoft.com/office/drawing/2014/main" id="{4A408C85-B377-2DB1-EF8F-00D922D8FA43}"/>
+              </a:ext>
+            </a:extLst>
+          </p:cNvPr>
+          <p:cNvSpPr>
+            <a:spLocks noGrp="1"/>
+          </p:cNvSpPr>
+          <p:nvPr>
+            <p:ph type="sldNum" sz="quarter" idx="12"/>
+          </p:nvPr>
+        </p:nvSpPr>
+        <p:spPr/>
+        <p:txBody>
+          <a:bodyPr/>
+          <a:lstStyle/>
+          <a:p>
+            <a:fld id="{7F469C41-6B9F-4AAA-9F31-D78B57F455E2}" type="slidenum">
+              <a:rPr lang="en-GB" smtClean="0"/>
+              <a:t>6</a:t>
+            </a:fld>
+            <a:endParaRPr lang="en-GB"/>
+          </a:p>
+        </p:txBody>
+      </p:sp>
+      <p:sp>
+        <p:nvSpPr>
+          <p:cNvPr id="14" name="Method card"/>
+          <p:cNvSpPr/>
+          <p:nvPr/>
+        </p:nvSpPr>
+        <p:spPr>
+          <a:xfrm>
+            <a:off x="841248" y="1554480"/>
+            <a:ext cx="7000000" cy="4050000"/>
+          </a:xfrm>
+          <a:prstGeom prst="roundRect">
+            <a:avLst>
+              <a:gd name="adj" fmla="val 6000"/>
+            </a:avLst>
+          </a:prstGeom>
+          <a:solidFill>
+            <a:srgbClr val="F1E9F7"/>
+          </a:solidFill>
+          <a:ln>
+            <a:noFill/>
+          </a:ln>
+          <a:effectLst/>
+        </p:spPr>
+        <p:style>
+          <a:lnRef idx="1">
+            <a:schemeClr val="accent1"/>
+          </a:lnRef>
+          <a:fillRef idx="3">
+            <a:schemeClr val="accent1"/>
+          </a:fillRef>
+          <a:effectRef idx="2">
+            <a:schemeClr val="accent1"/>
+          </a:effectRef>
+          <a:fontRef idx="minor">
+            <a:schemeClr val="lt1"/>
+          </a:fontRef>
+        </p:style>
+        <p:txBody>
+          <a:bodyPr rtlCol="0" anchor="ctr"/>
+          <a:lstStyle/>
+          <a:p>
+            <a:pPr algn="ctr"/>
+            <a:endParaRPr/>
+          </a:p>
+        </p:txBody>
+      </p:sp>
+      <p:pic>
+        <p:nvPicPr>
+          <p:cNvPr id="15" name="Picture 14" descr="gangenerated.png"/>
+          <p:cNvPicPr>
+            <a:picLocks noChangeAspect="1"/>
+          </p:cNvPicPr>
+          <p:nvPr/>
+        </p:nvPicPr>
+        <p:blipFill>
+          <a:blip r:embed="rId3"/>
+          <a:stretch>
+            <a:fillRect/>
+          </a:stretch>
+        </p:blipFill>
+        <p:spPr>
+          <a:xfrm>
+            <a:off x="1341248" y="1680000"/>
+            <a:ext cx="6000000" cy="3128072"/>
+          </a:xfrm>
+          <a:prstGeom prst="rect">
+            <a:avLst/>
+          </a:prstGeom>
+        </p:spPr>
+      </p:pic>
+      <p:sp>
+        <p:nvSpPr>
+          <p:cNvPr id="13" name="TextBox 12"/>
+          <p:cNvSpPr txBox="1"/>
+          <p:nvPr/>
+        </p:nvSpPr>
+        <p:spPr>
+          <a:xfrm>
+            <a:off x="941248" y="4898072"/>
+            <a:ext cx="6800000" cy="380000"/>
+          </a:xfrm>
+          <a:prstGeom prst="rect">
+            <a:avLst/>
+          </a:prstGeom>
+          <a:noFill/>
+        </p:spPr>
+        <p:txBody>
+          <a:bodyPr wrap="none" lIns="45720" tIns="27432" rIns="45720" bIns="27432" anchor="t">
+            <a:spAutoFit/>
+          </a:bodyPr>
+          <a:lstStyle/>
+          <a:p>
+            <a:pPr algn="ctr">
+              <a:spcAft>
+                <a:spcPts val="600"/>
+              </a:spcAft>
+            </a:pPr>
+            <a:r>
+              <a:rPr sz="1400" b="0" i="0">
+                <a:solidFill>
+                  <a:srgbClr val="222222"/>
+                </a:solidFill>
+                <a:latin typeface="Arial"/>
+              </a:rPr>
+              <a:t>Real GASF composite vs DCGAN-generated sample, same class</a:t>
+            </a:r>
+          </a:p>
+        </p:txBody>
+      </p:sp>
+      <p:sp>
+        <p:nvSpPr>
+          <p:cNvPr id="15" name="Stat card"/>
+          <p:cNvSpPr/>
+          <p:nvPr/>
+        </p:nvSpPr>
+        <p:spPr>
+          <a:xfrm>
+            <a:off x="8238160" y="1645920"/>
+            <a:ext cx="3118840" cy="4000000"/>
+          </a:xfrm>
+          <a:prstGeom prst="roundRect">
+            <a:avLst>
+              <a:gd name="adj" fmla="val 6000"/>
+            </a:avLst>
+          </a:prstGeom>
+          <a:solidFill>
+            <a:srgbClr val="6A2C91"/>
+          </a:solidFill>
+          <a:ln>
+            <a:noFill/>
+          </a:ln>
+          <a:effectLst/>
+        </p:spPr>
+        <p:style>
+          <a:lnRef idx="1">
+            <a:schemeClr val="accent1"/>
+          </a:lnRef>
+          <a:fillRef idx="3">
+            <a:schemeClr val="accent1"/>
+          </a:fillRef>
+          <a:effectRef idx="2">
+            <a:schemeClr val="accent1"/>
+          </a:effectRef>
+          <a:fontRef idx="minor">
+            <a:schemeClr val="lt1"/>
+          </a:fontRef>
+        </p:style>
+        <p:txBody>
+          <a:bodyPr rtlCol="0" anchor="ctr"/>
+          <a:lstStyle/>
+          <a:p>
+            <a:pPr algn="ctr"/>
+            <a:endParaRPr/>
+          </a:p>
+        </p:txBody>
+      </p:sp>
+      <p:sp>
+        <p:nvSpPr>
+          <p:cNvPr id="17" name="Stat label"/>
+          <p:cNvSpPr txBox="1"/>
+          <p:nvPr/>
+        </p:nvSpPr>
+        <p:spPr>
+          <a:xfrm>
+            <a:off x="8318160" y="1750000"/>
+            <a:ext cx="3000000" cy="3700000"/>
+          </a:xfrm>
+          <a:prstGeom prst="rect">
+            <a:avLst/>
+          </a:prstGeom>
+          <a:noFill/>
+        </p:spPr>
+        <p:txBody>
+          <a:bodyPr wrap="square" lIns="45720" tIns="27432" rIns="45720" bIns="27432" anchor="t">
+            <a:spAutoFit/>
+          </a:bodyPr>
+          <a:lstStyle/>
+          <a:p>
+            <a:pPr algn="l">
+              <a:spcAft>
+                <a:spcPts val="1000"/>
+              </a:spcAft>
+            </a:pPr>
+            <a:r>
+              <a:rPr sz="2000" b="1" i="0">
+                <a:solidFill>
+                  <a:srgbClr val="FFFFFF"/>
+                </a:solidFill>
+                <a:latin typeface="Arial"/>
+              </a:rPr>
+              <a:t>How it works</a:t>
+            </a:r>
+          </a:p>
+          <a:p>
+            <a:pPr algn="l">
+              <a:spcAft>
+                <a:spcPts val="1000"/>
+              </a:spcAft>
+            </a:pPr>
+            <a:r>
+              <a:rPr sz="1500" b="0" i="0">
+                <a:solidFill>
+                  <a:srgbClr val="FFFFFF"/>
+                </a:solidFill>
+                <a:latin typeface="Arial"/>
+              </a:rPr>
+              <a:t>A DCGAN learns the GASF composites of each under-represented class.</a:t>
+            </a:r>
+          </a:p>
+          <a:p>
+            <a:pPr algn="l">
+              <a:spcAft>
+                <a:spcPts val="1000"/>
+              </a:spcAft>
+            </a:pPr>
+            <a:r>
+              <a:rPr sz="1500" b="0" i="0">
+                <a:solidFill>
+                  <a:srgbClr val="FFFFFF"/>
+                </a:solidFill>
+                <a:latin typeface="Arial"/>
+              </a:rPr>
+              <a:t>Synthetic images are added to training folds only.</a:t>
+            </a:r>
+          </a:p>
+          <a:p>
+            <a:pPr algn="l">
+              <a:spcAft>
+                <a:spcPts val="1000"/>
+              </a:spcAft>
+            </a:pPr>
+            <a:r>
+              <a:rPr sz="1500" b="0" i="0">
+                <a:solidFill>
+                  <a:srgbClr val="FFFFFF"/>
+                </a:solidFill>
+                <a:latin typeface="Arial"/>
+              </a:rPr>
+              <a:t>Test folds stay 100% real, so there is no leakage.</a:t>
+            </a:r>
+          </a:p>
+        </p:txBody>
+      </p:sp>
+      <p:sp>
+        <p:nvSpPr>
+          <p:cNvPr id="32" name="Takeaway card"/>
+          <p:cNvSpPr/>
+          <p:nvPr/>
+        </p:nvSpPr>
+        <p:spPr>
+          <a:xfrm>
+            <a:off x="841248" y="5760720"/>
+            <a:ext cx="10515600" cy="548640"/>
+          </a:xfrm>
+          <a:prstGeom prst="roundRect">
+            <a:avLst>
+              <a:gd name="adj" fmla="val 6000"/>
+            </a:avLst>
+          </a:prstGeom>
+          <a:solidFill>
+            <a:srgbClr val="6A2C91"/>
+          </a:solidFill>
+          <a:ln>
+            <a:noFill/>
+          </a:ln>
+          <a:effectLst/>
+        </p:spPr>
+        <p:style>
+          <a:lnRef idx="1">
+            <a:schemeClr val="accent1"/>
+          </a:lnRef>
+          <a:fillRef idx="3">
+            <a:schemeClr val="accent1"/>
+          </a:fillRef>
+          <a:effectRef idx="2">
+            <a:schemeClr val="accent1"/>
+          </a:effectRef>
+          <a:fontRef idx="minor">
+            <a:schemeClr val="lt1"/>
+          </a:fontRef>
+        </p:style>
+        <p:txBody>
+          <a:bodyPr rtlCol="0" anchor="ctr"/>
+          <a:lstStyle/>
+          <a:p>
+            <a:pPr algn="ctr"/>
+            <a:endParaRPr/>
+          </a:p>
+        </p:txBody>
+      </p:sp>
+      <p:pic>
+        <p:nvPicPr>
+          <p:cNvPr id="33" name="Picture 32" descr="image.png"/>
+          <p:cNvPicPr>
+            <a:picLocks noChangeAspect="1"/>
+          </p:cNvPicPr>
+          <p:nvPr/>
+        </p:nvPicPr>
+        <p:blipFill>
+          <a:blip r:embed="rId4"/>
+          <a:stretch>
+            <a:fillRect/>
+          </a:stretch>
+        </p:blipFill>
+        <p:spPr>
+          <a:xfrm>
+            <a:off x="1069848" y="5870448"/>
+            <a:ext cx="329184" cy="329184"/>
+          </a:xfrm>
+          <a:prstGeom prst="rect">
+            <a:avLst/>
+          </a:prstGeom>
+        </p:spPr>
+      </p:pic>
+      <p:sp>
+        <p:nvSpPr>
+          <p:cNvPr id="34" name="Takeaway"/>
+          <p:cNvSpPr txBox="1"/>
+          <p:nvPr/>
+        </p:nvSpPr>
+        <p:spPr>
+          <a:xfrm>
+            <a:off x="1508760" y="5760720"/>
+            <a:ext cx="9601200" cy="548640"/>
+          </a:xfrm>
+          <a:prstGeom prst="rect">
+            <a:avLst/>
+          </a:prstGeom>
+          <a:noFill/>
+        </p:spPr>
+        <p:txBody>
+          <a:bodyPr wrap="square" lIns="45720" tIns="27432" rIns="45720" bIns="27432" anchor="ctr">
+            <a:spAutoFit/>
+          </a:bodyPr>
+          <a:lstStyle/>
+          <a:p>
+            <a:pPr algn="l">
+              <a:spcAft>
+                <a:spcPts val="600"/>
+              </a:spcAft>
+            </a:pPr>
+            <a:r>
+              <a:rPr sz="2000" b="1" i="0">
+                <a:solidFill>
+                  <a:srgbClr val="FFFFFF"/>
+                </a:solidFill>
+                <a:latin typeface="Arial"/>
+              </a:rPr>
+              <a:t>Synthetic samples keep the 4×4 channel layout and balance the classes</a:t>
+            </a:r>
+          </a:p>
+        </p:txBody>
+      </p:sp>
+    </p:spTree>
+  </p:cSld>
+  <p:clrMapOvr>
+    <a:masterClrMapping/>
+  </p:clrMapOvr>
+  <mc:AlternateContent xmlns:mc="http://schemas.openxmlformats.org/markup-compatibility/2006">
+    <mc:Choice xmlns:p14="http://schemas.microsoft.com/office/powerpoint/2010/main" Requires="p14">
+      <p:transition spd="med" p14:dur="700">
+        <p:push dir="l"/>
+      </p:transition>
+    </mc:Choice>
+    <mc:Fallback>
+      <p:transition spd="med">
+        <p:push dir="l"/>
       </p:transition>
     </mc:Fallback>
   </mc:AlternateContent>

</xml_diff>

<commit_message>
Replace morph with visible transitions on every slide
Co-Authored-By: Claude Sonnet 5.5 <noreply@anthropic.com>
</commit_message>
<xml_diff>
--- a/presentation/Systematic Evaluation of Signal-to-Image Transformation Pipelines for Vision Transformer-based Sleep Stage Classification - Presentation.pptx
+++ b/presentation/Systematic Evaluation of Signal-to-Image Transformation Pipelines for Vision Transformer-based Sleep Stage Classification - Presentation.pptx
@@ -6040,7 +6040,7 @@
   </p:clrMapOvr>
   <mc:AlternateContent xmlns:mc="http://schemas.openxmlformats.org/markup-compatibility/2006">
     <mc:Choice xmlns:p14="http://schemas.microsoft.com/office/powerpoint/2010/main" Requires="p14">
-      <p:transition spd="med" p14:dur="700">
+      <p:transition spd="med" p14:dur="800">
         <p:fade/>
       </p:transition>
     </mc:Choice>
@@ -6879,14 +6879,14 @@
     <a:masterClrMapping/>
   </p:clrMapOvr>
   <mc:AlternateContent xmlns:mc="http://schemas.openxmlformats.org/markup-compatibility/2006">
-    <mc:Choice xmlns:p159="http://schemas.microsoft.com/office/powerpoint/2015/09/main" xmlns:p14="http://schemas.microsoft.com/office/powerpoint/2010/main" Requires="p159">
-      <p:transition spd="slow" p14:dur="1200">
-        <p159:morph option="byObject"/>
+    <mc:Choice xmlns:p14="http://schemas.microsoft.com/office/powerpoint/2010/main" Requires="p14">
+      <p:transition spd="med" p14:dur="800">
+        <p:cover dir="l"/>
       </p:transition>
     </mc:Choice>
     <mc:Fallback>
-      <p:transition spd="slow">
-        <p:fade/>
+      <p:transition spd="med">
+        <p:cover dir="l"/>
       </p:transition>
     </mc:Fallback>
   </mc:AlternateContent>
@@ -7302,7 +7302,7 @@
   </p:clrMapOvr>
   <mc:AlternateContent xmlns:mc="http://schemas.openxmlformats.org/markup-compatibility/2006">
     <mc:Choice xmlns:p14="http://schemas.microsoft.com/office/powerpoint/2010/main" Requires="p14">
-      <p:transition spd="med" p14:dur="700">
+      <p:transition spd="med" p14:dur="800">
         <p:push dir="l"/>
       </p:transition>
     </mc:Choice>
@@ -8453,14 +8453,14 @@
     <a:masterClrMapping/>
   </p:clrMapOvr>
   <mc:AlternateContent xmlns:mc="http://schemas.openxmlformats.org/markup-compatibility/2006">
-    <mc:Choice xmlns:p159="http://schemas.microsoft.com/office/powerpoint/2015/09/main" xmlns:p14="http://schemas.microsoft.com/office/powerpoint/2010/main" Requires="p159">
-      <p:transition spd="slow" p14:dur="1200">
-        <p159:morph option="byObject"/>
+    <mc:Choice xmlns:p14="http://schemas.microsoft.com/office/powerpoint/2010/main" Requires="p14">
+      <p:transition spd="med" p14:dur="800">
+        <p:cover dir="l"/>
       </p:transition>
     </mc:Choice>
     <mc:Fallback>
-      <p:transition spd="slow">
-        <p:fade/>
+      <p:transition spd="med">
+        <p:cover dir="l"/>
       </p:transition>
     </mc:Fallback>
   </mc:AlternateContent>
@@ -8815,7 +8815,7 @@
   </p:clrMapOvr>
   <mc:AlternateContent xmlns:mc="http://schemas.openxmlformats.org/markup-compatibility/2006">
     <mc:Choice xmlns:p14="http://schemas.microsoft.com/office/powerpoint/2010/main" Requires="p14">
-      <p:transition spd="med" p14:dur="700">
+      <p:transition spd="med" p14:dur="800">
         <p:fade/>
       </p:transition>
     </mc:Choice>
@@ -9372,13 +9372,13 @@
   </p:clrMapOvr>
   <mc:AlternateContent xmlns:mc="http://schemas.openxmlformats.org/markup-compatibility/2006">
     <mc:Choice xmlns:p14="http://schemas.microsoft.com/office/powerpoint/2010/main" Requires="p14">
-      <p:transition spd="med" p14:dur="700">
-        <p:push dir="l"/>
+      <p:transition spd="med" p14:dur="800">
+        <p:split orient="vert" dir="out"/>
       </p:transition>
     </mc:Choice>
     <mc:Fallback>
       <p:transition spd="med">
-        <p:push dir="l"/>
+        <p:split orient="vert" dir="out"/>
       </p:transition>
     </mc:Fallback>
   </mc:AlternateContent>
@@ -9970,13 +9970,13 @@
   </p:clrMapOvr>
   <mc:AlternateContent xmlns:mc="http://schemas.openxmlformats.org/markup-compatibility/2006">
     <mc:Choice xmlns:p14="http://schemas.microsoft.com/office/powerpoint/2010/main" Requires="p14">
-      <p:transition spd="med" p14:dur="700">
-        <p:push dir="l"/>
+      <p:transition spd="med" p14:dur="800">
+        <p:split orient="vert" dir="out"/>
       </p:transition>
     </mc:Choice>
     <mc:Fallback>
       <p:transition spd="med">
-        <p:push dir="l"/>
+        <p:split orient="vert" dir="out"/>
       </p:transition>
     </mc:Fallback>
   </mc:AlternateContent>
@@ -10505,13 +10505,13 @@
   </p:clrMapOvr>
   <mc:AlternateContent xmlns:mc="http://schemas.openxmlformats.org/markup-compatibility/2006">
     <mc:Choice xmlns:p14="http://schemas.microsoft.com/office/powerpoint/2010/main" Requires="p14">
-      <p:transition spd="med" p14:dur="700">
-        <p:push dir="l"/>
+      <p:transition spd="med" p14:dur="800">
+        <p:split orient="vert" dir="out"/>
       </p:transition>
     </mc:Choice>
     <mc:Fallback>
       <p:transition spd="med">
-        <p:push dir="l"/>
+        <p:split orient="vert" dir="out"/>
       </p:transition>
     </mc:Fallback>
   </mc:AlternateContent>
@@ -11548,14 +11548,14 @@
     <a:masterClrMapping/>
   </p:clrMapOvr>
   <mc:AlternateContent xmlns:mc="http://schemas.openxmlformats.org/markup-compatibility/2006">
-    <mc:Choice xmlns:p159="http://schemas.microsoft.com/office/powerpoint/2015/09/main" xmlns:p14="http://schemas.microsoft.com/office/powerpoint/2010/main" Requires="p159">
-      <p:transition spd="slow" p14:dur="1200">
-        <p159:morph option="byObject"/>
+    <mc:Choice xmlns:p14="http://schemas.microsoft.com/office/powerpoint/2010/main" Requires="p14">
+      <p:transition spd="med" p14:dur="800">
+        <p:cover dir="l"/>
       </p:transition>
     </mc:Choice>
     <mc:Fallback>
-      <p:transition spd="slow">
-        <p:fade/>
+      <p:transition spd="med">
+        <p:cover dir="l"/>
       </p:transition>
     </mc:Fallback>
   </mc:AlternateContent>
@@ -12454,14 +12454,14 @@
     <a:masterClrMapping/>
   </p:clrMapOvr>
   <mc:AlternateContent xmlns:mc="http://schemas.openxmlformats.org/markup-compatibility/2006">
-    <mc:Choice xmlns:p159="http://schemas.microsoft.com/office/powerpoint/2015/09/main" xmlns:p14="http://schemas.microsoft.com/office/powerpoint/2010/main" Requires="p159">
-      <p:transition spd="slow" p14:dur="1200">
-        <p159:morph option="byObject"/>
+    <mc:Choice xmlns:p14="http://schemas.microsoft.com/office/powerpoint/2010/main" Requires="p14">
+      <p:transition spd="med" p14:dur="800">
+        <p:cover dir="l"/>
       </p:transition>
     </mc:Choice>
     <mc:Fallback>
-      <p:transition spd="slow">
-        <p:fade/>
+      <p:transition spd="med">
+        <p:cover dir="l"/>
       </p:transition>
     </mc:Fallback>
   </mc:AlternateContent>
@@ -13256,7 +13256,7 @@
   </p:clrMapOvr>
   <mc:AlternateContent xmlns:mc="http://schemas.openxmlformats.org/markup-compatibility/2006">
     <mc:Choice xmlns:p14="http://schemas.microsoft.com/office/powerpoint/2010/main" Requires="p14">
-      <p:transition spd="med" p14:dur="700">
+      <p:transition spd="med" p14:dur="800">
         <p:push dir="l"/>
       </p:transition>
     </mc:Choice>
@@ -13572,7 +13572,7 @@
   </p:clrMapOvr>
   <mc:AlternateContent xmlns:mc="http://schemas.openxmlformats.org/markup-compatibility/2006">
     <mc:Choice xmlns:p14="http://schemas.microsoft.com/office/powerpoint/2010/main" Requires="p14">
-      <p:transition spd="med" p14:dur="700">
+      <p:transition spd="med" p14:dur="800">
         <p:wipe dir="r"/>
       </p:transition>
     </mc:Choice>
@@ -14865,7 +14865,7 @@
   </p:clrMapOvr>
   <mc:AlternateContent xmlns:mc="http://schemas.openxmlformats.org/markup-compatibility/2006">
     <mc:Choice xmlns:p14="http://schemas.microsoft.com/office/powerpoint/2010/main" Requires="p14">
-      <p:transition spd="med" p14:dur="700">
+      <p:transition spd="med" p14:dur="800">
         <p:push dir="l"/>
       </p:transition>
     </mc:Choice>
@@ -15705,7 +15705,7 @@
   </p:clrMapOvr>
   <mc:AlternateContent xmlns:mc="http://schemas.openxmlformats.org/markup-compatibility/2006">
     <mc:Choice xmlns:p14="http://schemas.microsoft.com/office/powerpoint/2010/main" Requires="p14">
-      <p:transition spd="med" p14:dur="700">
+      <p:transition spd="med" p14:dur="800">
         <p:push dir="l"/>
       </p:transition>
     </mc:Choice>
@@ -16544,14 +16544,14 @@
     <a:masterClrMapping/>
   </p:clrMapOvr>
   <mc:AlternateContent xmlns:mc="http://schemas.openxmlformats.org/markup-compatibility/2006">
-    <mc:Choice xmlns:p159="http://schemas.microsoft.com/office/powerpoint/2015/09/main" xmlns:p14="http://schemas.microsoft.com/office/powerpoint/2010/main" Requires="p159">
-      <p:transition spd="slow" p14:dur="1200">
-        <p159:morph option="byObject"/>
+    <mc:Choice xmlns:p14="http://schemas.microsoft.com/office/powerpoint/2010/main" Requires="p14">
+      <p:transition spd="med" p14:dur="800">
+        <p:push dir="l"/>
       </p:transition>
     </mc:Choice>
     <mc:Fallback>
-      <p:transition spd="slow">
-        <p:fade/>
+      <p:transition spd="med">
+        <p:push dir="l"/>
       </p:transition>
     </mc:Fallback>
   </mc:AlternateContent>
@@ -17384,14 +17384,14 @@
     <a:masterClrMapping/>
   </p:clrMapOvr>
   <mc:AlternateContent xmlns:mc="http://schemas.openxmlformats.org/markup-compatibility/2006">
-    <mc:Choice xmlns:p159="http://schemas.microsoft.com/office/powerpoint/2015/09/main" xmlns:p14="http://schemas.microsoft.com/office/powerpoint/2010/main" Requires="p159">
-      <p:transition spd="slow" p14:dur="1200">
-        <p159:morph option="byObject"/>
+    <mc:Choice xmlns:p14="http://schemas.microsoft.com/office/powerpoint/2010/main" Requires="p14">
+      <p:transition spd="med" p14:dur="800">
+        <p:cover dir="l"/>
       </p:transition>
     </mc:Choice>
     <mc:Fallback>
-      <p:transition spd="slow">
-        <p:fade/>
+      <p:transition spd="med">
+        <p:cover dir="l"/>
       </p:transition>
     </mc:Fallback>
   </mc:AlternateContent>

</xml_diff>